<commit_message>
Added slides for document status and milestones in ietf125
</commit_message>
<xml_diff>
--- a/125/slides/slides-125-nmop-chair-slides-session1.pptx
+++ b/125/slides/slides-125-nmop-chair-slides-session1.pptx
@@ -6,7 +6,7 @@
     <p:sldMasterId id="2147483668" r:id="rId2"/>
   </p:sldMasterIdLst>
   <p:notesMasterIdLst>
-    <p:notesMasterId r:id="rId10"/>
+    <p:notesMasterId r:id="rId12"/>
   </p:notesMasterIdLst>
   <p:sldIdLst>
     <p:sldId id="276" r:id="rId3"/>
@@ -15,7 +15,9 @@
     <p:sldId id="259" r:id="rId6"/>
     <p:sldId id="261" r:id="rId7"/>
     <p:sldId id="278" r:id="rId8"/>
-    <p:sldId id="260" r:id="rId9"/>
+    <p:sldId id="283" r:id="rId9"/>
+    <p:sldId id="284" r:id="rId10"/>
+    <p:sldId id="260" r:id="rId11"/>
   </p:sldIdLst>
   <p:sldSz cx="9144000" cy="5143500" type="screen16x9"/>
   <p:notesSz cx="6858000" cy="9144000"/>
@@ -2654,6 +2656,1340 @@
 </file>
 
 <file path=ppt/notesSlides/notesSlide7.xml><?xml version="1.0" encoding="utf-8"?>
+<p:notes xmlns:a="http://schemas.openxmlformats.org/drawingml/2006/main" xmlns:r="http://schemas.openxmlformats.org/officeDocument/2006/relationships" xmlns:p="http://schemas.openxmlformats.org/presentationml/2006/main" showMasterSp="0" showMasterPhAnim="0">
+  <p:cSld>
+    <p:spTree>
+      <p:nvGrpSpPr>
+        <p:cNvPr id="1" name="Shape 65">
+          <a:extLst>
+            <a:ext uri="{FF2B5EF4-FFF2-40B4-BE49-F238E27FC236}">
+              <a16:creationId xmlns:a16="http://schemas.microsoft.com/office/drawing/2014/main" id="{1CCA91F2-C8BC-2B48-CF08-6EBC486FFB1C}"/>
+            </a:ext>
+          </a:extLst>
+        </p:cNvPr>
+        <p:cNvGrpSpPr/>
+        <p:nvPr/>
+      </p:nvGrpSpPr>
+      <p:grpSpPr>
+        <a:xfrm>
+          <a:off x="0" y="0"/>
+          <a:ext cx="0" cy="0"/>
+          <a:chOff x="0" y="0"/>
+          <a:chExt cx="0" cy="0"/>
+        </a:xfrm>
+      </p:grpSpPr>
+      <p:sp>
+        <p:nvSpPr>
+          <p:cNvPr id="66" name="Google Shape;66;g7179d949db_7_60:notes">
+            <a:extLst>
+              <a:ext uri="{FF2B5EF4-FFF2-40B4-BE49-F238E27FC236}">
+                <a16:creationId xmlns:a16="http://schemas.microsoft.com/office/drawing/2014/main" id="{F14264FF-CC51-9F3E-2958-38589B174310}"/>
+              </a:ext>
+            </a:extLst>
+          </p:cNvPr>
+          <p:cNvSpPr>
+            <a:spLocks noGrp="1" noRot="1" noChangeAspect="1"/>
+          </p:cNvSpPr>
+          <p:nvPr>
+            <p:ph type="sldImg" idx="2"/>
+          </p:nvPr>
+        </p:nvSpPr>
+        <p:spPr>
+          <a:xfrm>
+            <a:off x="381000" y="685800"/>
+            <a:ext cx="6096000" cy="3429000"/>
+          </a:xfrm>
+          <a:custGeom>
+            <a:avLst/>
+            <a:gdLst/>
+            <a:ahLst/>
+            <a:cxnLst/>
+            <a:rect l="l" t="t" r="r" b="b"/>
+            <a:pathLst>
+              <a:path w="120000" h="120000" extrusionOk="0">
+                <a:moveTo>
+                  <a:pt x="0" y="0"/>
+                </a:moveTo>
+                <a:lnTo>
+                  <a:pt x="120000" y="0"/>
+                </a:lnTo>
+                <a:lnTo>
+                  <a:pt x="120000" y="120000"/>
+                </a:lnTo>
+                <a:lnTo>
+                  <a:pt x="0" y="120000"/>
+                </a:lnTo>
+                <a:close/>
+              </a:path>
+            </a:pathLst>
+          </a:custGeom>
+          <a:noFill/>
+          <a:ln w="9525" cap="flat" cmpd="sng">
+            <a:solidFill>
+              <a:srgbClr val="000000"/>
+            </a:solidFill>
+            <a:prstDash val="solid"/>
+            <a:round/>
+            <a:headEnd type="none" w="sm" len="sm"/>
+            <a:tailEnd type="none" w="sm" len="sm"/>
+          </a:ln>
+        </p:spPr>
+      </p:sp>
+      <p:sp>
+        <p:nvSpPr>
+          <p:cNvPr id="67" name="Google Shape;67;g7179d949db_7_60:notes">
+            <a:extLst>
+              <a:ext uri="{FF2B5EF4-FFF2-40B4-BE49-F238E27FC236}">
+                <a16:creationId xmlns:a16="http://schemas.microsoft.com/office/drawing/2014/main" id="{EFCE72B6-2F25-ADE3-88C1-5CA6B5B046B2}"/>
+              </a:ext>
+            </a:extLst>
+          </p:cNvPr>
+          <p:cNvSpPr txBox="1">
+            <a:spLocks noGrp="1"/>
+          </p:cNvSpPr>
+          <p:nvPr>
+            <p:ph type="body" idx="1"/>
+          </p:nvPr>
+        </p:nvSpPr>
+        <p:spPr>
+          <a:xfrm>
+            <a:off x="685800" y="4343400"/>
+            <a:ext cx="5486400" cy="4114800"/>
+          </a:xfrm>
+          <a:prstGeom prst="rect">
+            <a:avLst/>
+          </a:prstGeom>
+          <a:noFill/>
+          <a:ln>
+            <a:noFill/>
+          </a:ln>
+        </p:spPr>
+        <p:txBody>
+          <a:bodyPr spcFirstLastPara="1" wrap="square" lIns="91425" tIns="91425" rIns="91425" bIns="91425" anchor="t" anchorCtr="0">
+            <a:noAutofit/>
+          </a:bodyPr>
+          <a:lstStyle/>
+          <a:p>
+            <a:pPr marL="0" lvl="0" indent="0" algn="l" rtl="0">
+              <a:lnSpc>
+                <a:spcPct val="115000"/>
+              </a:lnSpc>
+              <a:spcBef>
+                <a:spcPts val="0"/>
+              </a:spcBef>
+              <a:spcAft>
+                <a:spcPts val="0"/>
+              </a:spcAft>
+              <a:buNone/>
+            </a:pPr>
+            <a:r>
+              <a:rPr lang="en-US" sz="1200">
+                <a:solidFill>
+                  <a:srgbClr val="424242"/>
+                </a:solidFill>
+                <a:highlight>
+                  <a:srgbClr val="FFFFFF"/>
+                </a:highlight>
+                <a:latin typeface="Roboto"/>
+                <a:ea typeface="Roboto"/>
+                <a:cs typeface="Roboto"/>
+                <a:sym typeface="Roboto"/>
+              </a:rPr>
+              <a:t>The IETF Note Well should be shown at the start of every IETF working session. The guidance below is </a:t>
+            </a:r>
+            <a:r>
+              <a:rPr lang="en-US" sz="1200" u="sng">
+                <a:solidFill>
+                  <a:srgbClr val="1976D2"/>
+                </a:solidFill>
+                <a:latin typeface="Roboto"/>
+                <a:ea typeface="Roboto"/>
+                <a:cs typeface="Roboto"/>
+                <a:sym typeface="Roboto"/>
+                <a:hlinkClick r:id="rId3">
+                  <a:extLst>
+                    <a:ext uri="{A12FA001-AC4F-418D-AE19-62706E023703}">
+                      <ahyp:hlinkClr xmlns:ahyp="http://schemas.microsoft.com/office/drawing/2018/hyperlinkcolor" val="tx"/>
+                    </a:ext>
+                  </a:extLst>
+                </a:hlinkClick>
+              </a:rPr>
+              <a:t>adapted from IETF legal counsel presentation during IETF 120</a:t>
+            </a:r>
+            <a:endParaRPr sz="1200">
+              <a:solidFill>
+                <a:srgbClr val="1B5E20"/>
+              </a:solidFill>
+              <a:highlight>
+                <a:srgbClr val="E8F5E9"/>
+              </a:highlight>
+              <a:latin typeface="Roboto"/>
+              <a:ea typeface="Roboto"/>
+              <a:cs typeface="Roboto"/>
+              <a:sym typeface="Roboto"/>
+            </a:endParaRPr>
+          </a:p>
+          <a:p>
+            <a:pPr marL="0" lvl="0" indent="0" algn="l" rtl="0">
+              <a:lnSpc>
+                <a:spcPct val="115000"/>
+              </a:lnSpc>
+              <a:spcBef>
+                <a:spcPts val="0"/>
+              </a:spcBef>
+              <a:spcAft>
+                <a:spcPts val="0"/>
+              </a:spcAft>
+              <a:buNone/>
+            </a:pPr>
+            <a:endParaRPr sz="1200">
+              <a:solidFill>
+                <a:srgbClr val="1B5E20"/>
+              </a:solidFill>
+              <a:highlight>
+                <a:srgbClr val="E8F5E9"/>
+              </a:highlight>
+              <a:latin typeface="Roboto"/>
+              <a:ea typeface="Roboto"/>
+              <a:cs typeface="Roboto"/>
+              <a:sym typeface="Roboto"/>
+            </a:endParaRPr>
+          </a:p>
+          <a:p>
+            <a:pPr marL="0" lvl="0" indent="0" algn="l" rtl="0">
+              <a:lnSpc>
+                <a:spcPct val="115000"/>
+              </a:lnSpc>
+              <a:spcBef>
+                <a:spcPts val="0"/>
+              </a:spcBef>
+              <a:spcAft>
+                <a:spcPts val="0"/>
+              </a:spcAft>
+              <a:buClr>
+                <a:schemeClr val="dk1"/>
+              </a:buClr>
+              <a:buSzPts val="1100"/>
+              <a:buFont typeface="Arial"/>
+              <a:buNone/>
+            </a:pPr>
+            <a:r>
+              <a:rPr lang="en-US" sz="1200">
+                <a:solidFill>
+                  <a:srgbClr val="1B5E20"/>
+                </a:solidFill>
+                <a:highlight>
+                  <a:srgbClr val="E8F5E9"/>
+                </a:highlight>
+                <a:latin typeface="Roboto"/>
+                <a:ea typeface="Roboto"/>
+                <a:cs typeface="Roboto"/>
+                <a:sym typeface="Roboto"/>
+              </a:rPr>
+              <a:t>DO</a:t>
+            </a:r>
+            <a:endParaRPr sz="1200">
+              <a:solidFill>
+                <a:srgbClr val="1B5E20"/>
+              </a:solidFill>
+              <a:highlight>
+                <a:srgbClr val="E8F5E9"/>
+              </a:highlight>
+              <a:latin typeface="Roboto"/>
+              <a:ea typeface="Roboto"/>
+              <a:cs typeface="Roboto"/>
+              <a:sym typeface="Roboto"/>
+            </a:endParaRPr>
+          </a:p>
+          <a:p>
+            <a:pPr marL="457200" lvl="0" indent="-304800" algn="l" rtl="0">
+              <a:lnSpc>
+                <a:spcPct val="115000"/>
+              </a:lnSpc>
+              <a:spcBef>
+                <a:spcPts val="0"/>
+              </a:spcBef>
+              <a:spcAft>
+                <a:spcPts val="0"/>
+              </a:spcAft>
+              <a:buClr>
+                <a:srgbClr val="424242"/>
+              </a:buClr>
+              <a:buSzPts val="1200"/>
+              <a:buFont typeface="Roboto"/>
+              <a:buAutoNum type="arabicPeriod"/>
+            </a:pPr>
+            <a:r>
+              <a:rPr lang="en-US" sz="1200">
+                <a:solidFill>
+                  <a:srgbClr val="424242"/>
+                </a:solidFill>
+                <a:latin typeface="Roboto"/>
+                <a:ea typeface="Roboto"/>
+                <a:cs typeface="Roboto"/>
+                <a:sym typeface="Roboto"/>
+              </a:rPr>
+              <a:t>Do make sure people have enough time to read through the slide before you move on,</a:t>
+            </a:r>
+            <a:endParaRPr sz="1200">
+              <a:solidFill>
+                <a:srgbClr val="424242"/>
+              </a:solidFill>
+              <a:latin typeface="Roboto"/>
+              <a:ea typeface="Roboto"/>
+              <a:cs typeface="Roboto"/>
+              <a:sym typeface="Roboto"/>
+            </a:endParaRPr>
+          </a:p>
+          <a:p>
+            <a:pPr marL="457200" lvl="0" indent="-304800" algn="l" rtl="0">
+              <a:lnSpc>
+                <a:spcPct val="115000"/>
+              </a:lnSpc>
+              <a:spcBef>
+                <a:spcPts val="0"/>
+              </a:spcBef>
+              <a:spcAft>
+                <a:spcPts val="0"/>
+              </a:spcAft>
+              <a:buClr>
+                <a:srgbClr val="424242"/>
+              </a:buClr>
+              <a:buSzPts val="1200"/>
+              <a:buFont typeface="Roboto"/>
+              <a:buAutoNum type="arabicPeriod"/>
+            </a:pPr>
+            <a:r>
+              <a:rPr lang="en-US" sz="1200">
+                <a:solidFill>
+                  <a:srgbClr val="424242"/>
+                </a:solidFill>
+                <a:latin typeface="Roboto"/>
+                <a:ea typeface="Roboto"/>
+                <a:cs typeface="Roboto"/>
+                <a:sym typeface="Roboto"/>
+              </a:rPr>
+              <a:t>Do give a high-level summary of what’s covered in the Note Well: “IETF policies on conduct, privacy and IPR.”,</a:t>
+            </a:r>
+            <a:endParaRPr sz="1200">
+              <a:solidFill>
+                <a:srgbClr val="424242"/>
+              </a:solidFill>
+              <a:latin typeface="Roboto"/>
+              <a:ea typeface="Roboto"/>
+              <a:cs typeface="Roboto"/>
+              <a:sym typeface="Roboto"/>
+            </a:endParaRPr>
+          </a:p>
+          <a:p>
+            <a:pPr marL="457200" lvl="0" indent="-304800" algn="l" rtl="0">
+              <a:lnSpc>
+                <a:spcPct val="115000"/>
+              </a:lnSpc>
+              <a:spcBef>
+                <a:spcPts val="0"/>
+              </a:spcBef>
+              <a:spcAft>
+                <a:spcPts val="0"/>
+              </a:spcAft>
+              <a:buClr>
+                <a:srgbClr val="424242"/>
+              </a:buClr>
+              <a:buSzPts val="1200"/>
+              <a:buFont typeface="Roboto"/>
+              <a:buAutoNum type="arabicPeriod"/>
+            </a:pPr>
+            <a:r>
+              <a:rPr lang="en-US" sz="1200">
+                <a:solidFill>
+                  <a:srgbClr val="424242"/>
+                </a:solidFill>
+                <a:latin typeface="Roboto"/>
+                <a:ea typeface="Roboto"/>
+                <a:cs typeface="Roboto"/>
+                <a:sym typeface="Roboto"/>
+              </a:rPr>
+              <a:t>Do encourage people to read through all the linked policies &amp; documents in detail before participating or contributing,</a:t>
+            </a:r>
+            <a:endParaRPr sz="1200">
+              <a:solidFill>
+                <a:srgbClr val="424242"/>
+              </a:solidFill>
+              <a:latin typeface="Roboto"/>
+              <a:ea typeface="Roboto"/>
+              <a:cs typeface="Roboto"/>
+              <a:sym typeface="Roboto"/>
+            </a:endParaRPr>
+          </a:p>
+          <a:p>
+            <a:pPr marL="457200" lvl="0" indent="-304800" algn="l" rtl="0">
+              <a:lnSpc>
+                <a:spcPct val="115000"/>
+              </a:lnSpc>
+              <a:spcBef>
+                <a:spcPts val="0"/>
+              </a:spcBef>
+              <a:spcAft>
+                <a:spcPts val="0"/>
+              </a:spcAft>
+              <a:buClr>
+                <a:srgbClr val="424242"/>
+              </a:buClr>
+              <a:buSzPts val="1200"/>
+              <a:buFont typeface="Roboto"/>
+              <a:buAutoNum type="arabicPeriod"/>
+            </a:pPr>
+            <a:r>
+              <a:rPr lang="en-US" sz="1200">
+                <a:solidFill>
+                  <a:srgbClr val="424242"/>
+                </a:solidFill>
+                <a:latin typeface="Roboto"/>
+                <a:ea typeface="Roboto"/>
+                <a:cs typeface="Roboto"/>
+                <a:sym typeface="Roboto"/>
+              </a:rPr>
+              <a:t>Do explain where people can direct questions or concerns (IETF Executive Director or Ombudsteam).</a:t>
+            </a:r>
+            <a:endParaRPr sz="1200">
+              <a:solidFill>
+                <a:srgbClr val="424242"/>
+              </a:solidFill>
+              <a:latin typeface="Roboto"/>
+              <a:ea typeface="Roboto"/>
+              <a:cs typeface="Roboto"/>
+              <a:sym typeface="Roboto"/>
+            </a:endParaRPr>
+          </a:p>
+          <a:p>
+            <a:pPr marL="0" lvl="0" indent="0" algn="l" rtl="0">
+              <a:lnSpc>
+                <a:spcPct val="115000"/>
+              </a:lnSpc>
+              <a:spcBef>
+                <a:spcPts val="0"/>
+              </a:spcBef>
+              <a:spcAft>
+                <a:spcPts val="0"/>
+              </a:spcAft>
+              <a:buClr>
+                <a:schemeClr val="dk1"/>
+              </a:buClr>
+              <a:buSzPts val="1100"/>
+              <a:buFont typeface="Arial"/>
+              <a:buNone/>
+            </a:pPr>
+            <a:r>
+              <a:rPr lang="en-US" sz="1200">
+                <a:solidFill>
+                  <a:srgbClr val="B33F00"/>
+                </a:solidFill>
+                <a:highlight>
+                  <a:srgbClr val="FFF3E0"/>
+                </a:highlight>
+                <a:latin typeface="Roboto"/>
+                <a:ea typeface="Roboto"/>
+                <a:cs typeface="Roboto"/>
+                <a:sym typeface="Roboto"/>
+              </a:rPr>
+              <a:t>DON'T</a:t>
+            </a:r>
+            <a:endParaRPr sz="1200">
+              <a:solidFill>
+                <a:srgbClr val="B33F00"/>
+              </a:solidFill>
+              <a:highlight>
+                <a:srgbClr val="FFF3E0"/>
+              </a:highlight>
+              <a:latin typeface="Roboto"/>
+              <a:ea typeface="Roboto"/>
+              <a:cs typeface="Roboto"/>
+              <a:sym typeface="Roboto"/>
+            </a:endParaRPr>
+          </a:p>
+          <a:p>
+            <a:pPr marL="457200" lvl="0" indent="-304800" algn="l" rtl="0">
+              <a:lnSpc>
+                <a:spcPct val="115000"/>
+              </a:lnSpc>
+              <a:spcBef>
+                <a:spcPts val="0"/>
+              </a:spcBef>
+              <a:spcAft>
+                <a:spcPts val="0"/>
+              </a:spcAft>
+              <a:buClr>
+                <a:srgbClr val="424242"/>
+              </a:buClr>
+              <a:buSzPts val="1200"/>
+              <a:buFont typeface="Roboto"/>
+              <a:buAutoNum type="arabicPeriod"/>
+            </a:pPr>
+            <a:r>
+              <a:rPr lang="en-US" sz="1200">
+                <a:solidFill>
+                  <a:srgbClr val="424242"/>
+                </a:solidFill>
+                <a:latin typeface="Roboto"/>
+                <a:ea typeface="Roboto"/>
+                <a:cs typeface="Roboto"/>
+                <a:sym typeface="Roboto"/>
+              </a:rPr>
+              <a:t>Don’t dismiss the importance or relevance of any of the information on the Note Well.</a:t>
+            </a:r>
+            <a:endParaRPr sz="1200">
+              <a:solidFill>
+                <a:srgbClr val="424242"/>
+              </a:solidFill>
+              <a:latin typeface="Roboto"/>
+              <a:ea typeface="Roboto"/>
+              <a:cs typeface="Roboto"/>
+              <a:sym typeface="Roboto"/>
+            </a:endParaRPr>
+          </a:p>
+          <a:p>
+            <a:pPr marL="457200" lvl="0" indent="-304800" algn="l" rtl="0">
+              <a:lnSpc>
+                <a:spcPct val="115000"/>
+              </a:lnSpc>
+              <a:spcBef>
+                <a:spcPts val="0"/>
+              </a:spcBef>
+              <a:spcAft>
+                <a:spcPts val="0"/>
+              </a:spcAft>
+              <a:buClr>
+                <a:srgbClr val="424242"/>
+              </a:buClr>
+              <a:buSzPts val="1200"/>
+              <a:buFont typeface="Roboto"/>
+              <a:buAutoNum type="arabicPeriod"/>
+            </a:pPr>
+            <a:r>
+              <a:rPr lang="en-US" sz="1200">
+                <a:solidFill>
+                  <a:srgbClr val="424242"/>
+                </a:solidFill>
+                <a:latin typeface="Roboto"/>
+                <a:ea typeface="Roboto"/>
+                <a:cs typeface="Roboto"/>
+                <a:sym typeface="Roboto"/>
+              </a:rPr>
+              <a:t>Don’t interpret the meaning or get into the substance of any of the topics or content of the policies.</a:t>
+            </a:r>
+            <a:endParaRPr sz="1200">
+              <a:solidFill>
+                <a:srgbClr val="424242"/>
+              </a:solidFill>
+              <a:latin typeface="Roboto"/>
+              <a:ea typeface="Roboto"/>
+              <a:cs typeface="Roboto"/>
+              <a:sym typeface="Roboto"/>
+            </a:endParaRPr>
+          </a:p>
+          <a:p>
+            <a:pPr marL="457200" lvl="0" indent="-304800" algn="l" rtl="0">
+              <a:lnSpc>
+                <a:spcPct val="115000"/>
+              </a:lnSpc>
+              <a:spcBef>
+                <a:spcPts val="0"/>
+              </a:spcBef>
+              <a:spcAft>
+                <a:spcPts val="0"/>
+              </a:spcAft>
+              <a:buClr>
+                <a:srgbClr val="424242"/>
+              </a:buClr>
+              <a:buSzPts val="1200"/>
+              <a:buFont typeface="Roboto"/>
+              <a:buAutoNum type="arabicPeriod"/>
+            </a:pPr>
+            <a:r>
+              <a:rPr lang="en-US" sz="1200">
+                <a:solidFill>
+                  <a:srgbClr val="424242"/>
+                </a:solidFill>
+                <a:latin typeface="Roboto"/>
+                <a:ea typeface="Roboto"/>
+                <a:cs typeface="Roboto"/>
+                <a:sym typeface="Roboto"/>
+              </a:rPr>
+              <a:t>Don’t communicate that the Note Well conveys all the information participants need to know.</a:t>
+            </a:r>
+            <a:endParaRPr sz="1200">
+              <a:solidFill>
+                <a:srgbClr val="424242"/>
+              </a:solidFill>
+              <a:latin typeface="Roboto"/>
+              <a:ea typeface="Roboto"/>
+              <a:cs typeface="Roboto"/>
+              <a:sym typeface="Roboto"/>
+            </a:endParaRPr>
+          </a:p>
+          <a:p>
+            <a:pPr marL="457200" lvl="0" indent="-304800" algn="l" rtl="0">
+              <a:lnSpc>
+                <a:spcPct val="115000"/>
+              </a:lnSpc>
+              <a:spcBef>
+                <a:spcPts val="0"/>
+              </a:spcBef>
+              <a:spcAft>
+                <a:spcPts val="0"/>
+              </a:spcAft>
+              <a:buClr>
+                <a:srgbClr val="424242"/>
+              </a:buClr>
+              <a:buSzPts val="1200"/>
+              <a:buFont typeface="Roboto"/>
+              <a:buAutoNum type="arabicPeriod"/>
+            </a:pPr>
+            <a:r>
+              <a:rPr lang="en-US" sz="1200">
+                <a:solidFill>
+                  <a:srgbClr val="424242"/>
+                </a:solidFill>
+                <a:latin typeface="Roboto"/>
+                <a:ea typeface="Roboto"/>
+                <a:cs typeface="Roboto"/>
+                <a:sym typeface="Roboto"/>
+              </a:rPr>
+              <a:t>Don’t address questions or concerns in the meeting itself.</a:t>
+            </a:r>
+            <a:endParaRPr sz="1200">
+              <a:solidFill>
+                <a:srgbClr val="424242"/>
+              </a:solidFill>
+              <a:latin typeface="Roboto"/>
+              <a:ea typeface="Roboto"/>
+              <a:cs typeface="Roboto"/>
+              <a:sym typeface="Roboto"/>
+            </a:endParaRPr>
+          </a:p>
+          <a:p>
+            <a:pPr marL="0" lvl="0" indent="0" algn="l" rtl="0">
+              <a:lnSpc>
+                <a:spcPct val="115000"/>
+              </a:lnSpc>
+              <a:spcBef>
+                <a:spcPts val="0"/>
+              </a:spcBef>
+              <a:spcAft>
+                <a:spcPts val="0"/>
+              </a:spcAft>
+              <a:buClr>
+                <a:schemeClr val="dk1"/>
+              </a:buClr>
+              <a:buSzPts val="1100"/>
+              <a:buFont typeface="Arial"/>
+              <a:buNone/>
+            </a:pPr>
+            <a:endParaRPr sz="1200">
+              <a:solidFill>
+                <a:srgbClr val="424242"/>
+              </a:solidFill>
+              <a:latin typeface="Roboto"/>
+              <a:ea typeface="Roboto"/>
+              <a:cs typeface="Roboto"/>
+              <a:sym typeface="Roboto"/>
+            </a:endParaRPr>
+          </a:p>
+          <a:p>
+            <a:pPr marL="0" lvl="0" indent="0" algn="l" rtl="0">
+              <a:spcBef>
+                <a:spcPts val="0"/>
+              </a:spcBef>
+              <a:spcAft>
+                <a:spcPts val="0"/>
+              </a:spcAft>
+              <a:buNone/>
+            </a:pPr>
+            <a:endParaRPr/>
+          </a:p>
+        </p:txBody>
+      </p:sp>
+    </p:spTree>
+    <p:extLst>
+      <p:ext uri="{BB962C8B-B14F-4D97-AF65-F5344CB8AC3E}">
+        <p14:creationId xmlns:p14="http://schemas.microsoft.com/office/powerpoint/2010/main" val="3565868096"/>
+      </p:ext>
+    </p:extLst>
+  </p:cSld>
+  <p:clrMapOvr>
+    <a:masterClrMapping/>
+  </p:clrMapOvr>
+</p:notes>
+</file>
+
+<file path=ppt/notesSlides/notesSlide8.xml><?xml version="1.0" encoding="utf-8"?>
+<p:notes xmlns:a="http://schemas.openxmlformats.org/drawingml/2006/main" xmlns:r="http://schemas.openxmlformats.org/officeDocument/2006/relationships" xmlns:p="http://schemas.openxmlformats.org/presentationml/2006/main" showMasterSp="0" showMasterPhAnim="0">
+  <p:cSld>
+    <p:spTree>
+      <p:nvGrpSpPr>
+        <p:cNvPr id="1" name="Shape 65">
+          <a:extLst>
+            <a:ext uri="{FF2B5EF4-FFF2-40B4-BE49-F238E27FC236}">
+              <a16:creationId xmlns:a16="http://schemas.microsoft.com/office/drawing/2014/main" id="{ACC18DE4-3674-1039-B625-313C22FADB08}"/>
+            </a:ext>
+          </a:extLst>
+        </p:cNvPr>
+        <p:cNvGrpSpPr/>
+        <p:nvPr/>
+      </p:nvGrpSpPr>
+      <p:grpSpPr>
+        <a:xfrm>
+          <a:off x="0" y="0"/>
+          <a:ext cx="0" cy="0"/>
+          <a:chOff x="0" y="0"/>
+          <a:chExt cx="0" cy="0"/>
+        </a:xfrm>
+      </p:grpSpPr>
+      <p:sp>
+        <p:nvSpPr>
+          <p:cNvPr id="66" name="Google Shape;66;g7179d949db_7_60:notes">
+            <a:extLst>
+              <a:ext uri="{FF2B5EF4-FFF2-40B4-BE49-F238E27FC236}">
+                <a16:creationId xmlns:a16="http://schemas.microsoft.com/office/drawing/2014/main" id="{D5692017-F6A7-695D-3BC6-3EE40A5EE124}"/>
+              </a:ext>
+            </a:extLst>
+          </p:cNvPr>
+          <p:cNvSpPr>
+            <a:spLocks noGrp="1" noRot="1" noChangeAspect="1"/>
+          </p:cNvSpPr>
+          <p:nvPr>
+            <p:ph type="sldImg" idx="2"/>
+          </p:nvPr>
+        </p:nvSpPr>
+        <p:spPr>
+          <a:xfrm>
+            <a:off x="381000" y="685800"/>
+            <a:ext cx="6096000" cy="3429000"/>
+          </a:xfrm>
+          <a:custGeom>
+            <a:avLst/>
+            <a:gdLst/>
+            <a:ahLst/>
+            <a:cxnLst/>
+            <a:rect l="l" t="t" r="r" b="b"/>
+            <a:pathLst>
+              <a:path w="120000" h="120000" extrusionOk="0">
+                <a:moveTo>
+                  <a:pt x="0" y="0"/>
+                </a:moveTo>
+                <a:lnTo>
+                  <a:pt x="120000" y="0"/>
+                </a:lnTo>
+                <a:lnTo>
+                  <a:pt x="120000" y="120000"/>
+                </a:lnTo>
+                <a:lnTo>
+                  <a:pt x="0" y="120000"/>
+                </a:lnTo>
+                <a:close/>
+              </a:path>
+            </a:pathLst>
+          </a:custGeom>
+          <a:noFill/>
+          <a:ln w="9525" cap="flat" cmpd="sng">
+            <a:solidFill>
+              <a:srgbClr val="000000"/>
+            </a:solidFill>
+            <a:prstDash val="solid"/>
+            <a:round/>
+            <a:headEnd type="none" w="sm" len="sm"/>
+            <a:tailEnd type="none" w="sm" len="sm"/>
+          </a:ln>
+        </p:spPr>
+      </p:sp>
+      <p:sp>
+        <p:nvSpPr>
+          <p:cNvPr id="67" name="Google Shape;67;g7179d949db_7_60:notes">
+            <a:extLst>
+              <a:ext uri="{FF2B5EF4-FFF2-40B4-BE49-F238E27FC236}">
+                <a16:creationId xmlns:a16="http://schemas.microsoft.com/office/drawing/2014/main" id="{4F335127-292C-A2D2-94BD-1C02E3902546}"/>
+              </a:ext>
+            </a:extLst>
+          </p:cNvPr>
+          <p:cNvSpPr txBox="1">
+            <a:spLocks noGrp="1"/>
+          </p:cNvSpPr>
+          <p:nvPr>
+            <p:ph type="body" idx="1"/>
+          </p:nvPr>
+        </p:nvSpPr>
+        <p:spPr>
+          <a:xfrm>
+            <a:off x="685800" y="4343400"/>
+            <a:ext cx="5486400" cy="4114800"/>
+          </a:xfrm>
+          <a:prstGeom prst="rect">
+            <a:avLst/>
+          </a:prstGeom>
+          <a:noFill/>
+          <a:ln>
+            <a:noFill/>
+          </a:ln>
+        </p:spPr>
+        <p:txBody>
+          <a:bodyPr spcFirstLastPara="1" wrap="square" lIns="91425" tIns="91425" rIns="91425" bIns="91425" anchor="t" anchorCtr="0">
+            <a:noAutofit/>
+          </a:bodyPr>
+          <a:lstStyle/>
+          <a:p>
+            <a:pPr marL="0" lvl="0" indent="0" algn="l" rtl="0">
+              <a:lnSpc>
+                <a:spcPct val="115000"/>
+              </a:lnSpc>
+              <a:spcBef>
+                <a:spcPts val="0"/>
+              </a:spcBef>
+              <a:spcAft>
+                <a:spcPts val="0"/>
+              </a:spcAft>
+              <a:buNone/>
+            </a:pPr>
+            <a:r>
+              <a:rPr lang="en-US" sz="1200">
+                <a:solidFill>
+                  <a:srgbClr val="424242"/>
+                </a:solidFill>
+                <a:highlight>
+                  <a:srgbClr val="FFFFFF"/>
+                </a:highlight>
+                <a:latin typeface="Roboto"/>
+                <a:ea typeface="Roboto"/>
+                <a:cs typeface="Roboto"/>
+                <a:sym typeface="Roboto"/>
+              </a:rPr>
+              <a:t>The IETF Note Well should be shown at the start of every IETF working session. The guidance below is </a:t>
+            </a:r>
+            <a:r>
+              <a:rPr lang="en-US" sz="1200" u="sng">
+                <a:solidFill>
+                  <a:srgbClr val="1976D2"/>
+                </a:solidFill>
+                <a:latin typeface="Roboto"/>
+                <a:ea typeface="Roboto"/>
+                <a:cs typeface="Roboto"/>
+                <a:sym typeface="Roboto"/>
+                <a:hlinkClick r:id="rId3">
+                  <a:extLst>
+                    <a:ext uri="{A12FA001-AC4F-418D-AE19-62706E023703}">
+                      <ahyp:hlinkClr xmlns:ahyp="http://schemas.microsoft.com/office/drawing/2018/hyperlinkcolor" val="tx"/>
+                    </a:ext>
+                  </a:extLst>
+                </a:hlinkClick>
+              </a:rPr>
+              <a:t>adapted from IETF legal counsel presentation during IETF 120</a:t>
+            </a:r>
+            <a:endParaRPr sz="1200">
+              <a:solidFill>
+                <a:srgbClr val="1B5E20"/>
+              </a:solidFill>
+              <a:highlight>
+                <a:srgbClr val="E8F5E9"/>
+              </a:highlight>
+              <a:latin typeface="Roboto"/>
+              <a:ea typeface="Roboto"/>
+              <a:cs typeface="Roboto"/>
+              <a:sym typeface="Roboto"/>
+            </a:endParaRPr>
+          </a:p>
+          <a:p>
+            <a:pPr marL="0" lvl="0" indent="0" algn="l" rtl="0">
+              <a:lnSpc>
+                <a:spcPct val="115000"/>
+              </a:lnSpc>
+              <a:spcBef>
+                <a:spcPts val="0"/>
+              </a:spcBef>
+              <a:spcAft>
+                <a:spcPts val="0"/>
+              </a:spcAft>
+              <a:buNone/>
+            </a:pPr>
+            <a:endParaRPr sz="1200">
+              <a:solidFill>
+                <a:srgbClr val="1B5E20"/>
+              </a:solidFill>
+              <a:highlight>
+                <a:srgbClr val="E8F5E9"/>
+              </a:highlight>
+              <a:latin typeface="Roboto"/>
+              <a:ea typeface="Roboto"/>
+              <a:cs typeface="Roboto"/>
+              <a:sym typeface="Roboto"/>
+            </a:endParaRPr>
+          </a:p>
+          <a:p>
+            <a:pPr marL="0" lvl="0" indent="0" algn="l" rtl="0">
+              <a:lnSpc>
+                <a:spcPct val="115000"/>
+              </a:lnSpc>
+              <a:spcBef>
+                <a:spcPts val="0"/>
+              </a:spcBef>
+              <a:spcAft>
+                <a:spcPts val="0"/>
+              </a:spcAft>
+              <a:buClr>
+                <a:schemeClr val="dk1"/>
+              </a:buClr>
+              <a:buSzPts val="1100"/>
+              <a:buFont typeface="Arial"/>
+              <a:buNone/>
+            </a:pPr>
+            <a:r>
+              <a:rPr lang="en-US" sz="1200">
+                <a:solidFill>
+                  <a:srgbClr val="1B5E20"/>
+                </a:solidFill>
+                <a:highlight>
+                  <a:srgbClr val="E8F5E9"/>
+                </a:highlight>
+                <a:latin typeface="Roboto"/>
+                <a:ea typeface="Roboto"/>
+                <a:cs typeface="Roboto"/>
+                <a:sym typeface="Roboto"/>
+              </a:rPr>
+              <a:t>DO</a:t>
+            </a:r>
+            <a:endParaRPr sz="1200">
+              <a:solidFill>
+                <a:srgbClr val="1B5E20"/>
+              </a:solidFill>
+              <a:highlight>
+                <a:srgbClr val="E8F5E9"/>
+              </a:highlight>
+              <a:latin typeface="Roboto"/>
+              <a:ea typeface="Roboto"/>
+              <a:cs typeface="Roboto"/>
+              <a:sym typeface="Roboto"/>
+            </a:endParaRPr>
+          </a:p>
+          <a:p>
+            <a:pPr marL="457200" lvl="0" indent="-304800" algn="l" rtl="0">
+              <a:lnSpc>
+                <a:spcPct val="115000"/>
+              </a:lnSpc>
+              <a:spcBef>
+                <a:spcPts val="0"/>
+              </a:spcBef>
+              <a:spcAft>
+                <a:spcPts val="0"/>
+              </a:spcAft>
+              <a:buClr>
+                <a:srgbClr val="424242"/>
+              </a:buClr>
+              <a:buSzPts val="1200"/>
+              <a:buFont typeface="Roboto"/>
+              <a:buAutoNum type="arabicPeriod"/>
+            </a:pPr>
+            <a:r>
+              <a:rPr lang="en-US" sz="1200">
+                <a:solidFill>
+                  <a:srgbClr val="424242"/>
+                </a:solidFill>
+                <a:latin typeface="Roboto"/>
+                <a:ea typeface="Roboto"/>
+                <a:cs typeface="Roboto"/>
+                <a:sym typeface="Roboto"/>
+              </a:rPr>
+              <a:t>Do make sure people have enough time to read through the slide before you move on,</a:t>
+            </a:r>
+            <a:endParaRPr sz="1200">
+              <a:solidFill>
+                <a:srgbClr val="424242"/>
+              </a:solidFill>
+              <a:latin typeface="Roboto"/>
+              <a:ea typeface="Roboto"/>
+              <a:cs typeface="Roboto"/>
+              <a:sym typeface="Roboto"/>
+            </a:endParaRPr>
+          </a:p>
+          <a:p>
+            <a:pPr marL="457200" lvl="0" indent="-304800" algn="l" rtl="0">
+              <a:lnSpc>
+                <a:spcPct val="115000"/>
+              </a:lnSpc>
+              <a:spcBef>
+                <a:spcPts val="0"/>
+              </a:spcBef>
+              <a:spcAft>
+                <a:spcPts val="0"/>
+              </a:spcAft>
+              <a:buClr>
+                <a:srgbClr val="424242"/>
+              </a:buClr>
+              <a:buSzPts val="1200"/>
+              <a:buFont typeface="Roboto"/>
+              <a:buAutoNum type="arabicPeriod"/>
+            </a:pPr>
+            <a:r>
+              <a:rPr lang="en-US" sz="1200">
+                <a:solidFill>
+                  <a:srgbClr val="424242"/>
+                </a:solidFill>
+                <a:latin typeface="Roboto"/>
+                <a:ea typeface="Roboto"/>
+                <a:cs typeface="Roboto"/>
+                <a:sym typeface="Roboto"/>
+              </a:rPr>
+              <a:t>Do give a high-level summary of what’s covered in the Note Well: “IETF policies on conduct, privacy and IPR.”,</a:t>
+            </a:r>
+            <a:endParaRPr sz="1200">
+              <a:solidFill>
+                <a:srgbClr val="424242"/>
+              </a:solidFill>
+              <a:latin typeface="Roboto"/>
+              <a:ea typeface="Roboto"/>
+              <a:cs typeface="Roboto"/>
+              <a:sym typeface="Roboto"/>
+            </a:endParaRPr>
+          </a:p>
+          <a:p>
+            <a:pPr marL="457200" lvl="0" indent="-304800" algn="l" rtl="0">
+              <a:lnSpc>
+                <a:spcPct val="115000"/>
+              </a:lnSpc>
+              <a:spcBef>
+                <a:spcPts val="0"/>
+              </a:spcBef>
+              <a:spcAft>
+                <a:spcPts val="0"/>
+              </a:spcAft>
+              <a:buClr>
+                <a:srgbClr val="424242"/>
+              </a:buClr>
+              <a:buSzPts val="1200"/>
+              <a:buFont typeface="Roboto"/>
+              <a:buAutoNum type="arabicPeriod"/>
+            </a:pPr>
+            <a:r>
+              <a:rPr lang="en-US" sz="1200">
+                <a:solidFill>
+                  <a:srgbClr val="424242"/>
+                </a:solidFill>
+                <a:latin typeface="Roboto"/>
+                <a:ea typeface="Roboto"/>
+                <a:cs typeface="Roboto"/>
+                <a:sym typeface="Roboto"/>
+              </a:rPr>
+              <a:t>Do encourage people to read through all the linked policies &amp; documents in detail before participating or contributing,</a:t>
+            </a:r>
+            <a:endParaRPr sz="1200">
+              <a:solidFill>
+                <a:srgbClr val="424242"/>
+              </a:solidFill>
+              <a:latin typeface="Roboto"/>
+              <a:ea typeface="Roboto"/>
+              <a:cs typeface="Roboto"/>
+              <a:sym typeface="Roboto"/>
+            </a:endParaRPr>
+          </a:p>
+          <a:p>
+            <a:pPr marL="457200" lvl="0" indent="-304800" algn="l" rtl="0">
+              <a:lnSpc>
+                <a:spcPct val="115000"/>
+              </a:lnSpc>
+              <a:spcBef>
+                <a:spcPts val="0"/>
+              </a:spcBef>
+              <a:spcAft>
+                <a:spcPts val="0"/>
+              </a:spcAft>
+              <a:buClr>
+                <a:srgbClr val="424242"/>
+              </a:buClr>
+              <a:buSzPts val="1200"/>
+              <a:buFont typeface="Roboto"/>
+              <a:buAutoNum type="arabicPeriod"/>
+            </a:pPr>
+            <a:r>
+              <a:rPr lang="en-US" sz="1200">
+                <a:solidFill>
+                  <a:srgbClr val="424242"/>
+                </a:solidFill>
+                <a:latin typeface="Roboto"/>
+                <a:ea typeface="Roboto"/>
+                <a:cs typeface="Roboto"/>
+                <a:sym typeface="Roboto"/>
+              </a:rPr>
+              <a:t>Do explain where people can direct questions or concerns (IETF Executive Director or Ombudsteam).</a:t>
+            </a:r>
+            <a:endParaRPr sz="1200">
+              <a:solidFill>
+                <a:srgbClr val="424242"/>
+              </a:solidFill>
+              <a:latin typeface="Roboto"/>
+              <a:ea typeface="Roboto"/>
+              <a:cs typeface="Roboto"/>
+              <a:sym typeface="Roboto"/>
+            </a:endParaRPr>
+          </a:p>
+          <a:p>
+            <a:pPr marL="0" lvl="0" indent="0" algn="l" rtl="0">
+              <a:lnSpc>
+                <a:spcPct val="115000"/>
+              </a:lnSpc>
+              <a:spcBef>
+                <a:spcPts val="0"/>
+              </a:spcBef>
+              <a:spcAft>
+                <a:spcPts val="0"/>
+              </a:spcAft>
+              <a:buClr>
+                <a:schemeClr val="dk1"/>
+              </a:buClr>
+              <a:buSzPts val="1100"/>
+              <a:buFont typeface="Arial"/>
+              <a:buNone/>
+            </a:pPr>
+            <a:r>
+              <a:rPr lang="en-US" sz="1200">
+                <a:solidFill>
+                  <a:srgbClr val="B33F00"/>
+                </a:solidFill>
+                <a:highlight>
+                  <a:srgbClr val="FFF3E0"/>
+                </a:highlight>
+                <a:latin typeface="Roboto"/>
+                <a:ea typeface="Roboto"/>
+                <a:cs typeface="Roboto"/>
+                <a:sym typeface="Roboto"/>
+              </a:rPr>
+              <a:t>DON'T</a:t>
+            </a:r>
+            <a:endParaRPr sz="1200">
+              <a:solidFill>
+                <a:srgbClr val="B33F00"/>
+              </a:solidFill>
+              <a:highlight>
+                <a:srgbClr val="FFF3E0"/>
+              </a:highlight>
+              <a:latin typeface="Roboto"/>
+              <a:ea typeface="Roboto"/>
+              <a:cs typeface="Roboto"/>
+              <a:sym typeface="Roboto"/>
+            </a:endParaRPr>
+          </a:p>
+          <a:p>
+            <a:pPr marL="457200" lvl="0" indent="-304800" algn="l" rtl="0">
+              <a:lnSpc>
+                <a:spcPct val="115000"/>
+              </a:lnSpc>
+              <a:spcBef>
+                <a:spcPts val="0"/>
+              </a:spcBef>
+              <a:spcAft>
+                <a:spcPts val="0"/>
+              </a:spcAft>
+              <a:buClr>
+                <a:srgbClr val="424242"/>
+              </a:buClr>
+              <a:buSzPts val="1200"/>
+              <a:buFont typeface="Roboto"/>
+              <a:buAutoNum type="arabicPeriod"/>
+            </a:pPr>
+            <a:r>
+              <a:rPr lang="en-US" sz="1200">
+                <a:solidFill>
+                  <a:srgbClr val="424242"/>
+                </a:solidFill>
+                <a:latin typeface="Roboto"/>
+                <a:ea typeface="Roboto"/>
+                <a:cs typeface="Roboto"/>
+                <a:sym typeface="Roboto"/>
+              </a:rPr>
+              <a:t>Don’t dismiss the importance or relevance of any of the information on the Note Well.</a:t>
+            </a:r>
+            <a:endParaRPr sz="1200">
+              <a:solidFill>
+                <a:srgbClr val="424242"/>
+              </a:solidFill>
+              <a:latin typeface="Roboto"/>
+              <a:ea typeface="Roboto"/>
+              <a:cs typeface="Roboto"/>
+              <a:sym typeface="Roboto"/>
+            </a:endParaRPr>
+          </a:p>
+          <a:p>
+            <a:pPr marL="457200" lvl="0" indent="-304800" algn="l" rtl="0">
+              <a:lnSpc>
+                <a:spcPct val="115000"/>
+              </a:lnSpc>
+              <a:spcBef>
+                <a:spcPts val="0"/>
+              </a:spcBef>
+              <a:spcAft>
+                <a:spcPts val="0"/>
+              </a:spcAft>
+              <a:buClr>
+                <a:srgbClr val="424242"/>
+              </a:buClr>
+              <a:buSzPts val="1200"/>
+              <a:buFont typeface="Roboto"/>
+              <a:buAutoNum type="arabicPeriod"/>
+            </a:pPr>
+            <a:r>
+              <a:rPr lang="en-US" sz="1200">
+                <a:solidFill>
+                  <a:srgbClr val="424242"/>
+                </a:solidFill>
+                <a:latin typeface="Roboto"/>
+                <a:ea typeface="Roboto"/>
+                <a:cs typeface="Roboto"/>
+                <a:sym typeface="Roboto"/>
+              </a:rPr>
+              <a:t>Don’t interpret the meaning or get into the substance of any of the topics or content of the policies.</a:t>
+            </a:r>
+            <a:endParaRPr sz="1200">
+              <a:solidFill>
+                <a:srgbClr val="424242"/>
+              </a:solidFill>
+              <a:latin typeface="Roboto"/>
+              <a:ea typeface="Roboto"/>
+              <a:cs typeface="Roboto"/>
+              <a:sym typeface="Roboto"/>
+            </a:endParaRPr>
+          </a:p>
+          <a:p>
+            <a:pPr marL="457200" lvl="0" indent="-304800" algn="l" rtl="0">
+              <a:lnSpc>
+                <a:spcPct val="115000"/>
+              </a:lnSpc>
+              <a:spcBef>
+                <a:spcPts val="0"/>
+              </a:spcBef>
+              <a:spcAft>
+                <a:spcPts val="0"/>
+              </a:spcAft>
+              <a:buClr>
+                <a:srgbClr val="424242"/>
+              </a:buClr>
+              <a:buSzPts val="1200"/>
+              <a:buFont typeface="Roboto"/>
+              <a:buAutoNum type="arabicPeriod"/>
+            </a:pPr>
+            <a:r>
+              <a:rPr lang="en-US" sz="1200">
+                <a:solidFill>
+                  <a:srgbClr val="424242"/>
+                </a:solidFill>
+                <a:latin typeface="Roboto"/>
+                <a:ea typeface="Roboto"/>
+                <a:cs typeface="Roboto"/>
+                <a:sym typeface="Roboto"/>
+              </a:rPr>
+              <a:t>Don’t communicate that the Note Well conveys all the information participants need to know.</a:t>
+            </a:r>
+            <a:endParaRPr sz="1200">
+              <a:solidFill>
+                <a:srgbClr val="424242"/>
+              </a:solidFill>
+              <a:latin typeface="Roboto"/>
+              <a:ea typeface="Roboto"/>
+              <a:cs typeface="Roboto"/>
+              <a:sym typeface="Roboto"/>
+            </a:endParaRPr>
+          </a:p>
+          <a:p>
+            <a:pPr marL="457200" lvl="0" indent="-304800" algn="l" rtl="0">
+              <a:lnSpc>
+                <a:spcPct val="115000"/>
+              </a:lnSpc>
+              <a:spcBef>
+                <a:spcPts val="0"/>
+              </a:spcBef>
+              <a:spcAft>
+                <a:spcPts val="0"/>
+              </a:spcAft>
+              <a:buClr>
+                <a:srgbClr val="424242"/>
+              </a:buClr>
+              <a:buSzPts val="1200"/>
+              <a:buFont typeface="Roboto"/>
+              <a:buAutoNum type="arabicPeriod"/>
+            </a:pPr>
+            <a:r>
+              <a:rPr lang="en-US" sz="1200">
+                <a:solidFill>
+                  <a:srgbClr val="424242"/>
+                </a:solidFill>
+                <a:latin typeface="Roboto"/>
+                <a:ea typeface="Roboto"/>
+                <a:cs typeface="Roboto"/>
+                <a:sym typeface="Roboto"/>
+              </a:rPr>
+              <a:t>Don’t address questions or concerns in the meeting itself.</a:t>
+            </a:r>
+            <a:endParaRPr sz="1200">
+              <a:solidFill>
+                <a:srgbClr val="424242"/>
+              </a:solidFill>
+              <a:latin typeface="Roboto"/>
+              <a:ea typeface="Roboto"/>
+              <a:cs typeface="Roboto"/>
+              <a:sym typeface="Roboto"/>
+            </a:endParaRPr>
+          </a:p>
+          <a:p>
+            <a:pPr marL="0" lvl="0" indent="0" algn="l" rtl="0">
+              <a:lnSpc>
+                <a:spcPct val="115000"/>
+              </a:lnSpc>
+              <a:spcBef>
+                <a:spcPts val="0"/>
+              </a:spcBef>
+              <a:spcAft>
+                <a:spcPts val="0"/>
+              </a:spcAft>
+              <a:buClr>
+                <a:schemeClr val="dk1"/>
+              </a:buClr>
+              <a:buSzPts val="1100"/>
+              <a:buFont typeface="Arial"/>
+              <a:buNone/>
+            </a:pPr>
+            <a:endParaRPr sz="1200">
+              <a:solidFill>
+                <a:srgbClr val="424242"/>
+              </a:solidFill>
+              <a:latin typeface="Roboto"/>
+              <a:ea typeface="Roboto"/>
+              <a:cs typeface="Roboto"/>
+              <a:sym typeface="Roboto"/>
+            </a:endParaRPr>
+          </a:p>
+          <a:p>
+            <a:pPr marL="0" lvl="0" indent="0" algn="l" rtl="0">
+              <a:spcBef>
+                <a:spcPts val="0"/>
+              </a:spcBef>
+              <a:spcAft>
+                <a:spcPts val="0"/>
+              </a:spcAft>
+              <a:buNone/>
+            </a:pPr>
+            <a:endParaRPr/>
+          </a:p>
+        </p:txBody>
+      </p:sp>
+    </p:spTree>
+    <p:extLst>
+      <p:ext uri="{BB962C8B-B14F-4D97-AF65-F5344CB8AC3E}">
+        <p14:creationId xmlns:p14="http://schemas.microsoft.com/office/powerpoint/2010/main" val="3231734783"/>
+      </p:ext>
+    </p:extLst>
+  </p:cSld>
+  <p:clrMapOvr>
+    <a:masterClrMapping/>
+  </p:clrMapOvr>
+</p:notes>
+</file>
+
+<file path=ppt/notesSlides/notesSlide9.xml><?xml version="1.0" encoding="utf-8"?>
 <p:notes xmlns:a="http://schemas.openxmlformats.org/drawingml/2006/main" xmlns:r="http://schemas.openxmlformats.org/officeDocument/2006/relationships" xmlns:p="http://schemas.openxmlformats.org/presentationml/2006/main" showMasterSp="0" showMasterPhAnim="0">
   <p:cSld>
     <p:spTree>
@@ -19791,7 +21127,7 @@
         <p:fade/>
       </p:transition>
     </mc:Choice>
-    <mc:Fallback xmlns:ahyp="http://schemas.microsoft.com/office/drawing/2018/hyperlinkcolor" xmlns:p15="http://schemas.microsoft.com/office/powerpoint/2012/main" xmlns:com="http://schemas.openxmlformats.org/drawingml/2006/compatibility" xmlns:pvml="urn:schemas-microsoft-com:office:powerpoint" xmlns:v="urn:schemas-microsoft-com:vml" xmlns:o="urn:schemas-microsoft-com:office:office" xmlns:dgm="http://schemas.openxmlformats.org/drawingml/2006/diagram" xmlns:c="http://schemas.openxmlformats.org/drawingml/2006/chart" xmlns:mv="urn:schemas-microsoft-com:mac:vml" xmlns="">
+    <mc:Fallback xmlns="" xmlns:mv="urn:schemas-microsoft-com:mac:vml" xmlns:c="http://schemas.openxmlformats.org/drawingml/2006/chart" xmlns:dgm="http://schemas.openxmlformats.org/drawingml/2006/diagram" xmlns:o="urn:schemas-microsoft-com:office:office" xmlns:v="urn:schemas-microsoft-com:vml" xmlns:pvml="urn:schemas-microsoft-com:office:powerpoint" xmlns:com="http://schemas.openxmlformats.org/drawingml/2006/compatibility" xmlns:p15="http://schemas.microsoft.com/office/powerpoint/2012/main" xmlns:ahyp="http://schemas.microsoft.com/office/drawing/2018/hyperlinkcolor">
       <p:transition spd="slow">
         <p:fade/>
       </p:transition>
@@ -20114,7 +21450,7 @@
         <p:fade/>
       </p:transition>
     </mc:Choice>
-    <mc:Fallback xmlns:ahyp="http://schemas.microsoft.com/office/drawing/2018/hyperlinkcolor" xmlns:p15="http://schemas.microsoft.com/office/powerpoint/2012/main" xmlns:com="http://schemas.openxmlformats.org/drawingml/2006/compatibility" xmlns:pvml="urn:schemas-microsoft-com:office:powerpoint" xmlns:v="urn:schemas-microsoft-com:vml" xmlns:o="urn:schemas-microsoft-com:office:office" xmlns:dgm="http://schemas.openxmlformats.org/drawingml/2006/diagram" xmlns:c="http://schemas.openxmlformats.org/drawingml/2006/chart" xmlns:mv="urn:schemas-microsoft-com:mac:vml" xmlns="">
+    <mc:Fallback xmlns="" xmlns:mv="urn:schemas-microsoft-com:mac:vml" xmlns:c="http://schemas.openxmlformats.org/drawingml/2006/chart" xmlns:dgm="http://schemas.openxmlformats.org/drawingml/2006/diagram" xmlns:o="urn:schemas-microsoft-com:office:office" xmlns:v="urn:schemas-microsoft-com:vml" xmlns:pvml="urn:schemas-microsoft-com:office:powerpoint" xmlns:com="http://schemas.openxmlformats.org/drawingml/2006/compatibility" xmlns:p15="http://schemas.microsoft.com/office/powerpoint/2012/main" xmlns:ahyp="http://schemas.microsoft.com/office/drawing/2018/hyperlinkcolor">
       <p:transition spd="slow">
         <p:fade/>
       </p:transition>
@@ -21094,7 +22430,7 @@
         <p:fade/>
       </p:transition>
     </mc:Choice>
-    <mc:Fallback xmlns:ahyp="http://schemas.microsoft.com/office/drawing/2018/hyperlinkcolor" xmlns:p15="http://schemas.microsoft.com/office/powerpoint/2012/main" xmlns:com="http://schemas.openxmlformats.org/drawingml/2006/compatibility" xmlns:pvml="urn:schemas-microsoft-com:office:powerpoint" xmlns:v="urn:schemas-microsoft-com:vml" xmlns:o="urn:schemas-microsoft-com:office:office" xmlns:dgm="http://schemas.openxmlformats.org/drawingml/2006/diagram" xmlns:c="http://schemas.openxmlformats.org/drawingml/2006/chart" xmlns:mv="urn:schemas-microsoft-com:mac:vml" xmlns="">
+    <mc:Fallback xmlns="" xmlns:mv="urn:schemas-microsoft-com:mac:vml" xmlns:c="http://schemas.openxmlformats.org/drawingml/2006/chart" xmlns:dgm="http://schemas.openxmlformats.org/drawingml/2006/diagram" xmlns:o="urn:schemas-microsoft-com:office:office" xmlns:v="urn:schemas-microsoft-com:vml" xmlns:pvml="urn:schemas-microsoft-com:office:powerpoint" xmlns:com="http://schemas.openxmlformats.org/drawingml/2006/compatibility" xmlns:p15="http://schemas.microsoft.com/office/powerpoint/2012/main" xmlns:ahyp="http://schemas.microsoft.com/office/drawing/2018/hyperlinkcolor">
       <p:transition spd="slow">
         <p:fade/>
       </p:transition>
@@ -21104,6 +22440,1041 @@
 </file>
 
 <file path=ppt/slides/slide7.xml><?xml version="1.0" encoding="utf-8"?>
+<p:sld xmlns:a="http://schemas.openxmlformats.org/drawingml/2006/main" xmlns:r="http://schemas.openxmlformats.org/officeDocument/2006/relationships" xmlns:p="http://schemas.openxmlformats.org/presentationml/2006/main">
+  <p:cSld>
+    <p:spTree>
+      <p:nvGrpSpPr>
+        <p:cNvPr id="1" name="Shape 68">
+          <a:extLst>
+            <a:ext uri="{FF2B5EF4-FFF2-40B4-BE49-F238E27FC236}">
+              <a16:creationId xmlns:a16="http://schemas.microsoft.com/office/drawing/2014/main" id="{0B82840E-8823-51A0-8E43-3C993C1B0B9C}"/>
+            </a:ext>
+          </a:extLst>
+        </p:cNvPr>
+        <p:cNvGrpSpPr/>
+        <p:nvPr/>
+      </p:nvGrpSpPr>
+      <p:grpSpPr>
+        <a:xfrm>
+          <a:off x="0" y="0"/>
+          <a:ext cx="0" cy="0"/>
+          <a:chOff x="0" y="0"/>
+          <a:chExt cx="0" cy="0"/>
+        </a:xfrm>
+      </p:grpSpPr>
+      <p:pic>
+        <p:nvPicPr>
+          <p:cNvPr id="11" name="Picture 10" descr="A screenshot of a computer&#10;&#10;AI-generated content may be incorrect.">
+            <a:extLst>
+              <a:ext uri="{FF2B5EF4-FFF2-40B4-BE49-F238E27FC236}">
+                <a16:creationId xmlns:a16="http://schemas.microsoft.com/office/drawing/2014/main" id="{9E310682-4611-83BF-D44B-68AE8B9060A8}"/>
+              </a:ext>
+            </a:extLst>
+          </p:cNvPr>
+          <p:cNvPicPr>
+            <a:picLocks noChangeAspect="1"/>
+          </p:cNvPicPr>
+          <p:nvPr/>
+        </p:nvPicPr>
+        <p:blipFill>
+          <a:blip r:embed="rId3"/>
+          <a:stretch>
+            <a:fillRect/>
+          </a:stretch>
+        </p:blipFill>
+        <p:spPr>
+          <a:xfrm>
+            <a:off x="1" y="722269"/>
+            <a:ext cx="7251590" cy="4421231"/>
+          </a:xfrm>
+          <a:prstGeom prst="rect">
+            <a:avLst/>
+          </a:prstGeom>
+        </p:spPr>
+      </p:pic>
+      <p:sp>
+        <p:nvSpPr>
+          <p:cNvPr id="69" name="Google Shape;69;p12">
+            <a:extLst>
+              <a:ext uri="{FF2B5EF4-FFF2-40B4-BE49-F238E27FC236}">
+                <a16:creationId xmlns:a16="http://schemas.microsoft.com/office/drawing/2014/main" id="{379F77B1-2B3F-CAA6-FB67-67C4478615FD}"/>
+              </a:ext>
+            </a:extLst>
+          </p:cNvPr>
+          <p:cNvSpPr txBox="1">
+            <a:spLocks noGrp="1"/>
+          </p:cNvSpPr>
+          <p:nvPr>
+            <p:ph type="title"/>
+          </p:nvPr>
+        </p:nvSpPr>
+        <p:spPr>
+          <a:prstGeom prst="rect">
+            <a:avLst/>
+          </a:prstGeom>
+          <a:noFill/>
+          <a:ln>
+            <a:noFill/>
+          </a:ln>
+        </p:spPr>
+        <p:txBody>
+          <a:bodyPr spcFirstLastPara="1" wrap="square" lIns="91425" tIns="91425" rIns="91425" bIns="91425" anchor="b" anchorCtr="0">
+            <a:noAutofit/>
+          </a:bodyPr>
+          <a:lstStyle/>
+          <a:p>
+            <a:pPr marL="0" marR="0" lvl="0" indent="0" algn="l" rtl="0">
+              <a:lnSpc>
+                <a:spcPct val="100000"/>
+              </a:lnSpc>
+              <a:spcBef>
+                <a:spcPts val="0"/>
+              </a:spcBef>
+              <a:spcAft>
+                <a:spcPts val="0"/>
+              </a:spcAft>
+              <a:buClr>
+                <a:schemeClr val="lt1"/>
+              </a:buClr>
+              <a:buSzPts val="3200"/>
+              <a:buFont typeface="Open Sans SemiBold"/>
+              <a:buNone/>
+            </a:pPr>
+            <a:r>
+              <a:rPr lang="en-US" sz="2400" dirty="0">
+                <a:latin typeface="Inter"/>
+                <a:ea typeface="Inter"/>
+                <a:cs typeface="Inter"/>
+                <a:sym typeface="Inter"/>
+              </a:rPr>
+              <a:t>Document Status</a:t>
+            </a:r>
+            <a:endParaRPr sz="2400" i="0" u="none" strike="noStrike" cap="none" dirty="0">
+              <a:solidFill>
+                <a:schemeClr val="lt1"/>
+              </a:solidFill>
+              <a:latin typeface="Inter"/>
+              <a:ea typeface="Inter"/>
+              <a:cs typeface="Inter"/>
+              <a:sym typeface="Inter"/>
+            </a:endParaRPr>
+          </a:p>
+        </p:txBody>
+      </p:sp>
+      <p:sp>
+        <p:nvSpPr>
+          <p:cNvPr id="6" name="Bulle narrative : ronde 8">
+            <a:extLst>
+              <a:ext uri="{FF2B5EF4-FFF2-40B4-BE49-F238E27FC236}">
+                <a16:creationId xmlns:a16="http://schemas.microsoft.com/office/drawing/2014/main" id="{7810E069-5DC9-93DB-6EE3-4270F84AFED9}"/>
+              </a:ext>
+            </a:extLst>
+          </p:cNvPr>
+          <p:cNvSpPr/>
+          <p:nvPr/>
+        </p:nvSpPr>
+        <p:spPr>
+          <a:xfrm>
+            <a:off x="7325439" y="3637074"/>
+            <a:ext cx="1343250" cy="921123"/>
+          </a:xfrm>
+          <a:prstGeom prst="wedgeEllipseCallout">
+            <a:avLst>
+              <a:gd name="adj1" fmla="val -192507"/>
+              <a:gd name="adj2" fmla="val 61234"/>
+            </a:avLst>
+          </a:prstGeom>
+          <a:solidFill>
+            <a:schemeClr val="tx1"/>
+          </a:solidFill>
+          <a:ln>
+            <a:solidFill>
+              <a:schemeClr val="tx1"/>
+            </a:solidFill>
+          </a:ln>
+        </p:spPr>
+        <p:style>
+          <a:lnRef idx="2">
+            <a:schemeClr val="accent1">
+              <a:shade val="15000"/>
+            </a:schemeClr>
+          </a:lnRef>
+          <a:fillRef idx="1">
+            <a:schemeClr val="accent1"/>
+          </a:fillRef>
+          <a:effectRef idx="0">
+            <a:schemeClr val="accent1"/>
+          </a:effectRef>
+          <a:fontRef idx="minor">
+            <a:schemeClr val="lt1"/>
+          </a:fontRef>
+        </p:style>
+        <p:txBody>
+          <a:bodyPr rtlCol="0" anchor="ctr"/>
+          <a:lstStyle/>
+          <a:p>
+            <a:pPr algn="ctr"/>
+            <a:r>
+              <a:rPr lang="fr-FR" sz="1200" dirty="0">
+                <a:solidFill>
+                  <a:schemeClr val="accent4"/>
+                </a:solidFill>
+              </a:rPr>
+              <a:t>RFC Editor Queue</a:t>
+            </a:r>
+          </a:p>
+        </p:txBody>
+      </p:sp>
+      <p:sp>
+        <p:nvSpPr>
+          <p:cNvPr id="5" name="Bulle narrative : ronde 8">
+            <a:extLst>
+              <a:ext uri="{FF2B5EF4-FFF2-40B4-BE49-F238E27FC236}">
+                <a16:creationId xmlns:a16="http://schemas.microsoft.com/office/drawing/2014/main" id="{E67EEA6E-C123-F5BF-38D5-1E1611E7A6E0}"/>
+              </a:ext>
+            </a:extLst>
+          </p:cNvPr>
+          <p:cNvSpPr/>
+          <p:nvPr/>
+        </p:nvSpPr>
+        <p:spPr>
+          <a:xfrm>
+            <a:off x="7369099" y="2339545"/>
+            <a:ext cx="1255930" cy="921123"/>
+          </a:xfrm>
+          <a:prstGeom prst="wedgeEllipseCallout">
+            <a:avLst>
+              <a:gd name="adj1" fmla="val -212774"/>
+              <a:gd name="adj2" fmla="val -46760"/>
+            </a:avLst>
+          </a:prstGeom>
+          <a:solidFill>
+            <a:schemeClr val="tx1"/>
+          </a:solidFill>
+          <a:ln>
+            <a:solidFill>
+              <a:schemeClr val="tx1"/>
+            </a:solidFill>
+          </a:ln>
+        </p:spPr>
+        <p:style>
+          <a:lnRef idx="2">
+            <a:schemeClr val="accent1">
+              <a:shade val="15000"/>
+            </a:schemeClr>
+          </a:lnRef>
+          <a:fillRef idx="1">
+            <a:schemeClr val="accent1"/>
+          </a:fillRef>
+          <a:effectRef idx="0">
+            <a:schemeClr val="accent1"/>
+          </a:effectRef>
+          <a:fontRef idx="minor">
+            <a:schemeClr val="lt1"/>
+          </a:fontRef>
+        </p:style>
+        <p:txBody>
+          <a:bodyPr rtlCol="0" anchor="ctr"/>
+          <a:lstStyle/>
+          <a:p>
+            <a:pPr algn="ctr"/>
+            <a:r>
+              <a:rPr lang="fr-FR" sz="1200" dirty="0">
+                <a:solidFill>
+                  <a:schemeClr val="accent4"/>
+                </a:solidFill>
+              </a:rPr>
+              <a:t>WGLC</a:t>
+            </a:r>
+          </a:p>
+          <a:p>
+            <a:pPr algn="ctr"/>
+            <a:r>
+              <a:rPr lang="fr-FR" sz="1200" dirty="0" err="1">
+                <a:solidFill>
+                  <a:schemeClr val="accent4"/>
+                </a:solidFill>
+              </a:rPr>
+              <a:t>completed</a:t>
+            </a:r>
+            <a:endParaRPr lang="fr-FR" sz="1200" dirty="0">
+              <a:solidFill>
+                <a:schemeClr val="accent4"/>
+              </a:solidFill>
+            </a:endParaRPr>
+          </a:p>
+        </p:txBody>
+      </p:sp>
+      <p:sp>
+        <p:nvSpPr>
+          <p:cNvPr id="9" name="Bulle narrative : ronde 8">
+            <a:extLst>
+              <a:ext uri="{FF2B5EF4-FFF2-40B4-BE49-F238E27FC236}">
+                <a16:creationId xmlns:a16="http://schemas.microsoft.com/office/drawing/2014/main" id="{50BBA8CB-30AB-A916-E5F5-F7F3B5B40157}"/>
+              </a:ext>
+            </a:extLst>
+          </p:cNvPr>
+          <p:cNvSpPr/>
+          <p:nvPr/>
+        </p:nvSpPr>
+        <p:spPr>
+          <a:xfrm>
+            <a:off x="7325439" y="1330754"/>
+            <a:ext cx="1343250" cy="921123"/>
+          </a:xfrm>
+          <a:prstGeom prst="wedgeEllipseCallout">
+            <a:avLst>
+              <a:gd name="adj1" fmla="val -239468"/>
+              <a:gd name="adj2" fmla="val 18121"/>
+            </a:avLst>
+          </a:prstGeom>
+          <a:solidFill>
+            <a:schemeClr val="tx1"/>
+          </a:solidFill>
+          <a:ln>
+            <a:solidFill>
+              <a:schemeClr val="tx1"/>
+            </a:solidFill>
+          </a:ln>
+        </p:spPr>
+        <p:style>
+          <a:lnRef idx="2">
+            <a:schemeClr val="accent1">
+              <a:shade val="15000"/>
+            </a:schemeClr>
+          </a:lnRef>
+          <a:fillRef idx="1">
+            <a:schemeClr val="accent1"/>
+          </a:fillRef>
+          <a:effectRef idx="0">
+            <a:schemeClr val="accent1"/>
+          </a:effectRef>
+          <a:fontRef idx="minor">
+            <a:schemeClr val="lt1"/>
+          </a:fontRef>
+        </p:style>
+        <p:txBody>
+          <a:bodyPr rtlCol="0" anchor="ctr"/>
+          <a:lstStyle/>
+          <a:p>
+            <a:pPr algn="ctr"/>
+            <a:r>
+              <a:rPr lang="fr-FR" sz="1200" dirty="0" err="1">
+                <a:solidFill>
+                  <a:schemeClr val="accent4"/>
+                </a:solidFill>
+              </a:rPr>
+              <a:t>Adopted</a:t>
+            </a:r>
+            <a:r>
+              <a:rPr lang="fr-FR" sz="1200" dirty="0">
+                <a:solidFill>
+                  <a:schemeClr val="accent4"/>
+                </a:solidFill>
+              </a:rPr>
+              <a:t> </a:t>
+            </a:r>
+            <a:r>
+              <a:rPr lang="fr-FR" sz="1200" dirty="0" err="1">
+                <a:solidFill>
+                  <a:schemeClr val="accent4"/>
+                </a:solidFill>
+              </a:rPr>
+              <a:t>since</a:t>
+            </a:r>
+            <a:r>
+              <a:rPr lang="fr-FR" sz="1200" dirty="0">
+                <a:solidFill>
+                  <a:schemeClr val="accent4"/>
+                </a:solidFill>
+              </a:rPr>
+              <a:t> </a:t>
+            </a:r>
+          </a:p>
+          <a:p>
+            <a:pPr algn="ctr"/>
+            <a:r>
+              <a:rPr lang="fr-FR" sz="1200" dirty="0">
+                <a:solidFill>
+                  <a:schemeClr val="accent4"/>
+                </a:solidFill>
+              </a:rPr>
+              <a:t>IETF 124</a:t>
+            </a:r>
+          </a:p>
+        </p:txBody>
+      </p:sp>
+      <p:sp>
+        <p:nvSpPr>
+          <p:cNvPr id="2" name="Slide Number Placeholder 1">
+            <a:extLst>
+              <a:ext uri="{FF2B5EF4-FFF2-40B4-BE49-F238E27FC236}">
+                <a16:creationId xmlns:a16="http://schemas.microsoft.com/office/drawing/2014/main" id="{6E72AC35-771D-1C2B-0578-89488CAFEE38}"/>
+              </a:ext>
+            </a:extLst>
+          </p:cNvPr>
+          <p:cNvSpPr>
+            <a:spLocks noGrp="1"/>
+          </p:cNvSpPr>
+          <p:nvPr>
+            <p:ph type="sldNum" idx="12"/>
+          </p:nvPr>
+        </p:nvSpPr>
+        <p:spPr/>
+        <p:txBody>
+          <a:bodyPr/>
+          <a:lstStyle/>
+          <a:p>
+            <a:pPr marL="0" lvl="0" indent="0" algn="r" rtl="0">
+              <a:spcBef>
+                <a:spcPts val="0"/>
+              </a:spcBef>
+              <a:spcAft>
+                <a:spcPts val="0"/>
+              </a:spcAft>
+              <a:buNone/>
+            </a:pPr>
+            <a:fld id="{00000000-1234-1234-1234-123412341234}" type="slidenum">
+              <a:rPr lang="en-US" smtClean="0"/>
+              <a:t>7</a:t>
+            </a:fld>
+            <a:endParaRPr lang="en-US"/>
+          </a:p>
+        </p:txBody>
+      </p:sp>
+    </p:spTree>
+    <p:extLst>
+      <p:ext uri="{BB962C8B-B14F-4D97-AF65-F5344CB8AC3E}">
+        <p14:creationId xmlns:p14="http://schemas.microsoft.com/office/powerpoint/2010/main" val="244518723"/>
+      </p:ext>
+    </p:extLst>
+  </p:cSld>
+  <p:clrMapOvr>
+    <a:masterClrMapping/>
+  </p:clrMapOvr>
+  <mc:AlternateContent xmlns:mc="http://schemas.openxmlformats.org/markup-compatibility/2006">
+    <mc:Choice xmlns:p14="http://schemas.microsoft.com/office/powerpoint/2010/main" Requires="p14">
+      <p:transition spd="med" p14:dur="700">
+        <p:fade/>
+      </p:transition>
+    </mc:Choice>
+    <mc:Fallback>
+      <p:transition spd="med">
+        <p:fade/>
+      </p:transition>
+    </mc:Fallback>
+  </mc:AlternateContent>
+</p:sld>
+</file>
+
+<file path=ppt/slides/slide8.xml><?xml version="1.0" encoding="utf-8"?>
+<p:sld xmlns:a="http://schemas.openxmlformats.org/drawingml/2006/main" xmlns:r="http://schemas.openxmlformats.org/officeDocument/2006/relationships" xmlns:p="http://schemas.openxmlformats.org/presentationml/2006/main">
+  <p:cSld>
+    <p:spTree>
+      <p:nvGrpSpPr>
+        <p:cNvPr id="1" name="Shape 68">
+          <a:extLst>
+            <a:ext uri="{FF2B5EF4-FFF2-40B4-BE49-F238E27FC236}">
+              <a16:creationId xmlns:a16="http://schemas.microsoft.com/office/drawing/2014/main" id="{88CB9E5A-4BCD-3230-FEAB-A29C5726CC5C}"/>
+            </a:ext>
+          </a:extLst>
+        </p:cNvPr>
+        <p:cNvGrpSpPr/>
+        <p:nvPr/>
+      </p:nvGrpSpPr>
+      <p:grpSpPr>
+        <a:xfrm>
+          <a:off x="0" y="0"/>
+          <a:ext cx="0" cy="0"/>
+          <a:chOff x="0" y="0"/>
+          <a:chExt cx="0" cy="0"/>
+        </a:xfrm>
+      </p:grpSpPr>
+      <p:pic>
+        <p:nvPicPr>
+          <p:cNvPr id="6" name="Picture 5" descr="A screenshot of a computer&#10;&#10;AI-generated content may be incorrect.">
+            <a:extLst>
+              <a:ext uri="{FF2B5EF4-FFF2-40B4-BE49-F238E27FC236}">
+                <a16:creationId xmlns:a16="http://schemas.microsoft.com/office/drawing/2014/main" id="{8D6D560B-7609-16AA-9338-C28B483AA08C}"/>
+              </a:ext>
+            </a:extLst>
+          </p:cNvPr>
+          <p:cNvPicPr>
+            <a:picLocks noChangeAspect="1"/>
+          </p:cNvPicPr>
+          <p:nvPr/>
+        </p:nvPicPr>
+        <p:blipFill>
+          <a:blip r:embed="rId3"/>
+          <a:stretch>
+            <a:fillRect/>
+          </a:stretch>
+        </p:blipFill>
+        <p:spPr>
+          <a:xfrm>
+            <a:off x="0" y="764084"/>
+            <a:ext cx="6639339" cy="3960714"/>
+          </a:xfrm>
+          <a:prstGeom prst="rect">
+            <a:avLst/>
+          </a:prstGeom>
+        </p:spPr>
+      </p:pic>
+      <p:sp>
+        <p:nvSpPr>
+          <p:cNvPr id="69" name="Google Shape;69;p12">
+            <a:extLst>
+              <a:ext uri="{FF2B5EF4-FFF2-40B4-BE49-F238E27FC236}">
+                <a16:creationId xmlns:a16="http://schemas.microsoft.com/office/drawing/2014/main" id="{2A43BCAF-5DA5-B0AC-C636-6A1E6CC4BC91}"/>
+              </a:ext>
+            </a:extLst>
+          </p:cNvPr>
+          <p:cNvSpPr txBox="1">
+            <a:spLocks noGrp="1"/>
+          </p:cNvSpPr>
+          <p:nvPr>
+            <p:ph type="title"/>
+          </p:nvPr>
+        </p:nvSpPr>
+        <p:spPr>
+          <a:prstGeom prst="rect">
+            <a:avLst/>
+          </a:prstGeom>
+          <a:noFill/>
+          <a:ln>
+            <a:noFill/>
+          </a:ln>
+        </p:spPr>
+        <p:txBody>
+          <a:bodyPr spcFirstLastPara="1" wrap="square" lIns="91425" tIns="91425" rIns="91425" bIns="91425" anchor="b" anchorCtr="0">
+            <a:noAutofit/>
+          </a:bodyPr>
+          <a:lstStyle/>
+          <a:p>
+            <a:pPr marL="0" marR="0" lvl="0" indent="0" algn="l" rtl="0">
+              <a:lnSpc>
+                <a:spcPct val="100000"/>
+              </a:lnSpc>
+              <a:spcBef>
+                <a:spcPts val="0"/>
+              </a:spcBef>
+              <a:spcAft>
+                <a:spcPts val="0"/>
+              </a:spcAft>
+              <a:buClr>
+                <a:schemeClr val="lt1"/>
+              </a:buClr>
+              <a:buSzPts val="3200"/>
+              <a:buFont typeface="Open Sans SemiBold"/>
+              <a:buNone/>
+            </a:pPr>
+            <a:r>
+              <a:rPr lang="en-US" sz="2400" dirty="0">
+                <a:latin typeface="Inter"/>
+                <a:ea typeface="Inter"/>
+                <a:cs typeface="Inter"/>
+                <a:sym typeface="Inter"/>
+              </a:rPr>
+              <a:t>Milestones</a:t>
+            </a:r>
+            <a:endParaRPr sz="2400" i="0" u="none" strike="noStrike" cap="none" dirty="0">
+              <a:solidFill>
+                <a:schemeClr val="lt1"/>
+              </a:solidFill>
+              <a:latin typeface="Inter"/>
+              <a:ea typeface="Inter"/>
+              <a:cs typeface="Inter"/>
+              <a:sym typeface="Inter"/>
+            </a:endParaRPr>
+          </a:p>
+        </p:txBody>
+      </p:sp>
+      <p:sp>
+        <p:nvSpPr>
+          <p:cNvPr id="2" name="Espace réservé du numéro de diapositive 3">
+            <a:extLst>
+              <a:ext uri="{FF2B5EF4-FFF2-40B4-BE49-F238E27FC236}">
+                <a16:creationId xmlns:a16="http://schemas.microsoft.com/office/drawing/2014/main" id="{716BD65A-A7D1-C93B-D733-28C06AEAEA7B}"/>
+              </a:ext>
+            </a:extLst>
+          </p:cNvPr>
+          <p:cNvSpPr>
+            <a:spLocks noGrp="1"/>
+          </p:cNvSpPr>
+          <p:nvPr>
+            <p:ph type="sldNum" idx="12"/>
+          </p:nvPr>
+        </p:nvSpPr>
+        <p:spPr>
+          <a:xfrm>
+            <a:off x="8735428" y="4724798"/>
+            <a:ext cx="336813" cy="335251"/>
+          </a:xfrm>
+        </p:spPr>
+        <p:txBody>
+          <a:bodyPr/>
+          <a:lstStyle/>
+          <a:p>
+            <a:pPr marL="0" lvl="0" indent="0" algn="r" rtl="0">
+              <a:spcBef>
+                <a:spcPts val="0"/>
+              </a:spcBef>
+              <a:spcAft>
+                <a:spcPts val="0"/>
+              </a:spcAft>
+              <a:buNone/>
+            </a:pPr>
+            <a:fld id="{00000000-1234-1234-1234-123412341234}" type="slidenum">
+              <a:rPr lang="en-US" smtClean="0"/>
+              <a:t>8</a:t>
+            </a:fld>
+            <a:endParaRPr lang="en-US"/>
+          </a:p>
+        </p:txBody>
+      </p:sp>
+      <p:sp>
+        <p:nvSpPr>
+          <p:cNvPr id="4" name="ZoneTexte 6">
+            <a:extLst>
+              <a:ext uri="{FF2B5EF4-FFF2-40B4-BE49-F238E27FC236}">
+                <a16:creationId xmlns:a16="http://schemas.microsoft.com/office/drawing/2014/main" id="{70A0EB0D-FFD8-257A-C3B2-95B60C879AEF}"/>
+              </a:ext>
+            </a:extLst>
+          </p:cNvPr>
+          <p:cNvSpPr txBox="1"/>
+          <p:nvPr/>
+        </p:nvSpPr>
+        <p:spPr>
+          <a:xfrm>
+            <a:off x="7195738" y="2001856"/>
+            <a:ext cx="1734616" cy="307777"/>
+          </a:xfrm>
+          <a:prstGeom prst="rect">
+            <a:avLst/>
+          </a:prstGeom>
+          <a:noFill/>
+        </p:spPr>
+        <p:txBody>
+          <a:bodyPr wrap="square" rtlCol="0">
+            <a:spAutoFit/>
+          </a:bodyPr>
+          <a:lstStyle/>
+          <a:p>
+            <a:r>
+              <a:rPr lang="fr-FR" dirty="0" err="1">
+                <a:solidFill>
+                  <a:srgbClr val="00B0F0"/>
+                </a:solidFill>
+              </a:rPr>
+              <a:t>November</a:t>
+            </a:r>
+            <a:r>
+              <a:rPr lang="fr-FR" dirty="0">
+                <a:solidFill>
+                  <a:srgbClr val="00B0F0"/>
+                </a:solidFill>
+              </a:rPr>
+              <a:t> 2026 </a:t>
+            </a:r>
+          </a:p>
+        </p:txBody>
+      </p:sp>
+      <p:sp>
+        <p:nvSpPr>
+          <p:cNvPr id="7" name="Flèche : gauche 7">
+            <a:extLst>
+              <a:ext uri="{FF2B5EF4-FFF2-40B4-BE49-F238E27FC236}">
+                <a16:creationId xmlns:a16="http://schemas.microsoft.com/office/drawing/2014/main" id="{987DD165-3EA1-DE30-8657-AC8F90B5CD0A}"/>
+              </a:ext>
+            </a:extLst>
+          </p:cNvPr>
+          <p:cNvSpPr/>
+          <p:nvPr/>
+        </p:nvSpPr>
+        <p:spPr>
+          <a:xfrm>
+            <a:off x="6391069" y="2038083"/>
+            <a:ext cx="804669" cy="235324"/>
+          </a:xfrm>
+          <a:prstGeom prst="leftArrow">
+            <a:avLst/>
+          </a:prstGeom>
+          <a:solidFill>
+            <a:srgbClr val="00B0F0"/>
+          </a:solidFill>
+          <a:ln>
+            <a:solidFill>
+              <a:srgbClr val="00B0F0"/>
+            </a:solidFill>
+          </a:ln>
+        </p:spPr>
+        <p:style>
+          <a:lnRef idx="2">
+            <a:schemeClr val="accent1">
+              <a:shade val="15000"/>
+            </a:schemeClr>
+          </a:lnRef>
+          <a:fillRef idx="1">
+            <a:schemeClr val="accent1"/>
+          </a:fillRef>
+          <a:effectRef idx="0">
+            <a:schemeClr val="accent1"/>
+          </a:effectRef>
+          <a:fontRef idx="minor">
+            <a:schemeClr val="lt1"/>
+          </a:fontRef>
+        </p:style>
+        <p:txBody>
+          <a:bodyPr rtlCol="0" anchor="ctr"/>
+          <a:lstStyle/>
+          <a:p>
+            <a:pPr algn="ctr"/>
+            <a:endParaRPr lang="fr-FR"/>
+          </a:p>
+        </p:txBody>
+      </p:sp>
+      <p:sp>
+        <p:nvSpPr>
+          <p:cNvPr id="11" name="ZoneTexte 6">
+            <a:extLst>
+              <a:ext uri="{FF2B5EF4-FFF2-40B4-BE49-F238E27FC236}">
+                <a16:creationId xmlns:a16="http://schemas.microsoft.com/office/drawing/2014/main" id="{5B03F52C-E45F-D4A0-03F7-961B312B0011}"/>
+              </a:ext>
+            </a:extLst>
+          </p:cNvPr>
+          <p:cNvSpPr txBox="1"/>
+          <p:nvPr/>
+        </p:nvSpPr>
+        <p:spPr>
+          <a:xfrm>
+            <a:off x="7195738" y="1323935"/>
+            <a:ext cx="1539690" cy="307777"/>
+          </a:xfrm>
+          <a:prstGeom prst="rect">
+            <a:avLst/>
+          </a:prstGeom>
+          <a:noFill/>
+        </p:spPr>
+        <p:txBody>
+          <a:bodyPr wrap="square" rtlCol="0">
+            <a:spAutoFit/>
+          </a:bodyPr>
+          <a:lstStyle/>
+          <a:p>
+            <a:r>
+              <a:rPr lang="fr-FR" dirty="0">
+                <a:solidFill>
+                  <a:srgbClr val="00B0F0"/>
+                </a:solidFill>
+              </a:rPr>
+              <a:t>Our </a:t>
+            </a:r>
+            <a:r>
+              <a:rPr lang="fr-FR" dirty="0" err="1">
+                <a:solidFill>
+                  <a:srgbClr val="00B0F0"/>
+                </a:solidFill>
+              </a:rPr>
+              <a:t>next</a:t>
+            </a:r>
+            <a:r>
+              <a:rPr lang="fr-FR" dirty="0">
+                <a:solidFill>
+                  <a:srgbClr val="00B0F0"/>
+                </a:solidFill>
+              </a:rPr>
+              <a:t> </a:t>
+            </a:r>
+            <a:r>
+              <a:rPr lang="fr-FR" dirty="0" err="1">
+                <a:solidFill>
+                  <a:srgbClr val="00B0F0"/>
+                </a:solidFill>
+              </a:rPr>
+              <a:t>target</a:t>
+            </a:r>
+            <a:endParaRPr lang="fr-FR" dirty="0">
+              <a:solidFill>
+                <a:srgbClr val="00B0F0"/>
+              </a:solidFill>
+            </a:endParaRPr>
+          </a:p>
+        </p:txBody>
+      </p:sp>
+      <p:sp>
+        <p:nvSpPr>
+          <p:cNvPr id="12" name="Flèche : gauche 7">
+            <a:extLst>
+              <a:ext uri="{FF2B5EF4-FFF2-40B4-BE49-F238E27FC236}">
+                <a16:creationId xmlns:a16="http://schemas.microsoft.com/office/drawing/2014/main" id="{4482C08A-EB0E-D7DF-7808-723DF4355C3C}"/>
+              </a:ext>
+            </a:extLst>
+          </p:cNvPr>
+          <p:cNvSpPr/>
+          <p:nvPr/>
+        </p:nvSpPr>
+        <p:spPr>
+          <a:xfrm>
+            <a:off x="6391069" y="1360162"/>
+            <a:ext cx="804669" cy="235324"/>
+          </a:xfrm>
+          <a:prstGeom prst="leftArrow">
+            <a:avLst/>
+          </a:prstGeom>
+          <a:solidFill>
+            <a:srgbClr val="00B0F0"/>
+          </a:solidFill>
+          <a:ln>
+            <a:solidFill>
+              <a:srgbClr val="00B0F0"/>
+            </a:solidFill>
+          </a:ln>
+        </p:spPr>
+        <p:style>
+          <a:lnRef idx="2">
+            <a:schemeClr val="accent1">
+              <a:shade val="15000"/>
+            </a:schemeClr>
+          </a:lnRef>
+          <a:fillRef idx="1">
+            <a:schemeClr val="accent1"/>
+          </a:fillRef>
+          <a:effectRef idx="0">
+            <a:schemeClr val="accent1"/>
+          </a:effectRef>
+          <a:fontRef idx="minor">
+            <a:schemeClr val="lt1"/>
+          </a:fontRef>
+        </p:style>
+        <p:txBody>
+          <a:bodyPr rtlCol="0" anchor="ctr"/>
+          <a:lstStyle/>
+          <a:p>
+            <a:pPr algn="ctr"/>
+            <a:endParaRPr lang="fr-FR"/>
+          </a:p>
+        </p:txBody>
+      </p:sp>
+      <p:sp>
+        <p:nvSpPr>
+          <p:cNvPr id="13" name="ZoneTexte 6">
+            <a:extLst>
+              <a:ext uri="{FF2B5EF4-FFF2-40B4-BE49-F238E27FC236}">
+                <a16:creationId xmlns:a16="http://schemas.microsoft.com/office/drawing/2014/main" id="{2E5BCDC2-6B92-ED2D-C725-0E0A92673469}"/>
+              </a:ext>
+            </a:extLst>
+          </p:cNvPr>
+          <p:cNvSpPr txBox="1"/>
+          <p:nvPr/>
+        </p:nvSpPr>
+        <p:spPr>
+          <a:xfrm>
+            <a:off x="7195738" y="2327747"/>
+            <a:ext cx="1734616" cy="307777"/>
+          </a:xfrm>
+          <a:prstGeom prst="rect">
+            <a:avLst/>
+          </a:prstGeom>
+          <a:noFill/>
+        </p:spPr>
+        <p:txBody>
+          <a:bodyPr wrap="square" rtlCol="0">
+            <a:spAutoFit/>
+          </a:bodyPr>
+          <a:lstStyle/>
+          <a:p>
+            <a:r>
+              <a:rPr lang="fr-FR" dirty="0" err="1">
+                <a:solidFill>
+                  <a:srgbClr val="00B0F0"/>
+                </a:solidFill>
+              </a:rPr>
+              <a:t>November</a:t>
+            </a:r>
+            <a:r>
+              <a:rPr lang="fr-FR" dirty="0">
+                <a:solidFill>
+                  <a:srgbClr val="00B0F0"/>
+                </a:solidFill>
+              </a:rPr>
+              <a:t> 2026 </a:t>
+            </a:r>
+          </a:p>
+        </p:txBody>
+      </p:sp>
+      <p:sp>
+        <p:nvSpPr>
+          <p:cNvPr id="14" name="Flèche : gauche 7">
+            <a:extLst>
+              <a:ext uri="{FF2B5EF4-FFF2-40B4-BE49-F238E27FC236}">
+                <a16:creationId xmlns:a16="http://schemas.microsoft.com/office/drawing/2014/main" id="{F731843A-3705-54E2-5AB0-9F390B2A6C9B}"/>
+              </a:ext>
+            </a:extLst>
+          </p:cNvPr>
+          <p:cNvSpPr/>
+          <p:nvPr/>
+        </p:nvSpPr>
+        <p:spPr>
+          <a:xfrm>
+            <a:off x="6391069" y="2363974"/>
+            <a:ext cx="804669" cy="235324"/>
+          </a:xfrm>
+          <a:prstGeom prst="leftArrow">
+            <a:avLst/>
+          </a:prstGeom>
+          <a:solidFill>
+            <a:srgbClr val="00B0F0"/>
+          </a:solidFill>
+          <a:ln>
+            <a:solidFill>
+              <a:srgbClr val="00B0F0"/>
+            </a:solidFill>
+          </a:ln>
+        </p:spPr>
+        <p:style>
+          <a:lnRef idx="2">
+            <a:schemeClr val="accent1">
+              <a:shade val="15000"/>
+            </a:schemeClr>
+          </a:lnRef>
+          <a:fillRef idx="1">
+            <a:schemeClr val="accent1"/>
+          </a:fillRef>
+          <a:effectRef idx="0">
+            <a:schemeClr val="accent1"/>
+          </a:effectRef>
+          <a:fontRef idx="minor">
+            <a:schemeClr val="lt1"/>
+          </a:fontRef>
+        </p:style>
+        <p:txBody>
+          <a:bodyPr rtlCol="0" anchor="ctr"/>
+          <a:lstStyle/>
+          <a:p>
+            <a:pPr algn="ctr"/>
+            <a:endParaRPr lang="fr-FR"/>
+          </a:p>
+        </p:txBody>
+      </p:sp>
+      <p:sp>
+        <p:nvSpPr>
+          <p:cNvPr id="8" name="ZoneTexte 6">
+            <a:extLst>
+              <a:ext uri="{FF2B5EF4-FFF2-40B4-BE49-F238E27FC236}">
+                <a16:creationId xmlns:a16="http://schemas.microsoft.com/office/drawing/2014/main" id="{DC70A2FB-01A0-E46E-0EE7-2F6E6965D843}"/>
+              </a:ext>
+            </a:extLst>
+          </p:cNvPr>
+          <p:cNvSpPr txBox="1"/>
+          <p:nvPr/>
+        </p:nvSpPr>
+        <p:spPr>
+          <a:xfrm>
+            <a:off x="7195738" y="1671072"/>
+            <a:ext cx="1734616" cy="307777"/>
+          </a:xfrm>
+          <a:prstGeom prst="rect">
+            <a:avLst/>
+          </a:prstGeom>
+          <a:noFill/>
+        </p:spPr>
+        <p:txBody>
+          <a:bodyPr wrap="square" rtlCol="0">
+            <a:spAutoFit/>
+          </a:bodyPr>
+          <a:lstStyle/>
+          <a:p>
+            <a:r>
+              <a:rPr lang="fr-FR" dirty="0">
+                <a:solidFill>
+                  <a:srgbClr val="00B0F0"/>
+                </a:solidFill>
+              </a:rPr>
+              <a:t>July 2026 </a:t>
+            </a:r>
+          </a:p>
+        </p:txBody>
+      </p:sp>
+      <p:sp>
+        <p:nvSpPr>
+          <p:cNvPr id="9" name="Flèche : gauche 7">
+            <a:extLst>
+              <a:ext uri="{FF2B5EF4-FFF2-40B4-BE49-F238E27FC236}">
+                <a16:creationId xmlns:a16="http://schemas.microsoft.com/office/drawing/2014/main" id="{B311E8CD-04F7-DBC8-231B-CB7F32AA3367}"/>
+              </a:ext>
+            </a:extLst>
+          </p:cNvPr>
+          <p:cNvSpPr/>
+          <p:nvPr/>
+        </p:nvSpPr>
+        <p:spPr>
+          <a:xfrm>
+            <a:off x="6391069" y="1707299"/>
+            <a:ext cx="804669" cy="235324"/>
+          </a:xfrm>
+          <a:prstGeom prst="leftArrow">
+            <a:avLst/>
+          </a:prstGeom>
+          <a:solidFill>
+            <a:srgbClr val="00B0F0"/>
+          </a:solidFill>
+          <a:ln>
+            <a:solidFill>
+              <a:srgbClr val="00B0F0"/>
+            </a:solidFill>
+          </a:ln>
+        </p:spPr>
+        <p:style>
+          <a:lnRef idx="2">
+            <a:schemeClr val="accent1">
+              <a:shade val="15000"/>
+            </a:schemeClr>
+          </a:lnRef>
+          <a:fillRef idx="1">
+            <a:schemeClr val="accent1"/>
+          </a:fillRef>
+          <a:effectRef idx="0">
+            <a:schemeClr val="accent1"/>
+          </a:effectRef>
+          <a:fontRef idx="minor">
+            <a:schemeClr val="lt1"/>
+          </a:fontRef>
+        </p:style>
+        <p:txBody>
+          <a:bodyPr rtlCol="0" anchor="ctr"/>
+          <a:lstStyle/>
+          <a:p>
+            <a:pPr algn="ctr"/>
+            <a:endParaRPr lang="fr-FR"/>
+          </a:p>
+        </p:txBody>
+      </p:sp>
+    </p:spTree>
+    <p:extLst>
+      <p:ext uri="{BB962C8B-B14F-4D97-AF65-F5344CB8AC3E}">
+        <p14:creationId xmlns:p14="http://schemas.microsoft.com/office/powerpoint/2010/main" val="924157570"/>
+      </p:ext>
+    </p:extLst>
+  </p:cSld>
+  <p:clrMapOvr>
+    <a:masterClrMapping/>
+  </p:clrMapOvr>
+  <mc:AlternateContent xmlns:mc="http://schemas.openxmlformats.org/markup-compatibility/2006">
+    <mc:Choice xmlns:p14="http://schemas.microsoft.com/office/powerpoint/2010/main" Requires="p14">
+      <p:transition spd="med" p14:dur="700">
+        <p:fade/>
+      </p:transition>
+    </mc:Choice>
+    <mc:Fallback>
+      <p:transition spd="med">
+        <p:fade/>
+      </p:transition>
+    </mc:Fallback>
+  </mc:AlternateContent>
+</p:sld>
+</file>
+
+<file path=ppt/slides/slide9.xml><?xml version="1.0" encoding="utf-8"?>
 <p:sld xmlns:a="http://schemas.openxmlformats.org/drawingml/2006/main" xmlns:r="http://schemas.openxmlformats.org/officeDocument/2006/relationships" xmlns:p="http://schemas.openxmlformats.org/presentationml/2006/main" show="0">
   <p:cSld>
     <p:spTree>
@@ -21450,7 +23821,7 @@
             </a:pPr>
             <a:fld id="{00000000-1234-1234-1234-123412341234}" type="slidenum">
               <a:rPr lang="en-US"/>
-              <a:t>7</a:t>
+              <a:t>9</a:t>
             </a:fld>
             <a:endParaRPr dirty="0"/>
           </a:p>

</xml_diff>